<commit_message>
Minor changes to W6S3.
</commit_message>
<xml_diff>
--- a/W6/W6S3 - Token1/W6S3.pptx
+++ b/W6/W6S3 - Token1/W6S3.pptx
@@ -335,7 +335,7 @@
   <pc:docChgLst>
     <pc:chgData name="Matthieu De Mari" userId="dfb708c9-d8dc-439f-9a3b-c772bf4a311c" providerId="ADAL" clId="{81E9B007-0C2C-493E-9B93-55A62C9C1F12}"/>
     <pc:docChg chg="modSld">
-      <pc:chgData name="Matthieu De Mari" userId="dfb708c9-d8dc-439f-9a3b-c772bf4a311c" providerId="ADAL" clId="{81E9B007-0C2C-493E-9B93-55A62C9C1F12}" dt="2026-03-03T10:07:45.476" v="3" actId="20577"/>
+      <pc:chgData name="Matthieu De Mari" userId="dfb708c9-d8dc-439f-9a3b-c772bf4a311c" providerId="ADAL" clId="{81E9B007-0C2C-493E-9B93-55A62C9C1F12}" dt="2026-03-05T04:45:32.466" v="14" actId="20577"/>
       <pc:docMkLst>
         <pc:docMk/>
       </pc:docMkLst>
@@ -351,6 +351,66 @@
             <pc:docMk/>
             <pc:sldMk cId="1040156172" sldId="377"/>
             <ac:spMk id="2" creationId="{080CEB46-CC16-4D19-8C2C-AEE9471D8168}"/>
+          </ac:spMkLst>
+        </pc:spChg>
+      </pc:sldChg>
+      <pc:sldChg chg="modSp mod">
+        <pc:chgData name="Matthieu De Mari" userId="dfb708c9-d8dc-439f-9a3b-c772bf4a311c" providerId="ADAL" clId="{81E9B007-0C2C-493E-9B93-55A62C9C1F12}" dt="2026-03-05T04:31:49.787" v="4" actId="20577"/>
+        <pc:sldMkLst>
+          <pc:docMk/>
+          <pc:sldMk cId="3287206519" sldId="445"/>
+        </pc:sldMkLst>
+        <pc:spChg chg="mod">
+          <ac:chgData name="Matthieu De Mari" userId="dfb708c9-d8dc-439f-9a3b-c772bf4a311c" providerId="ADAL" clId="{81E9B007-0C2C-493E-9B93-55A62C9C1F12}" dt="2026-03-05T04:31:49.787" v="4" actId="20577"/>
+          <ac:spMkLst>
+            <pc:docMk/>
+            <pc:sldMk cId="3287206519" sldId="445"/>
+            <ac:spMk id="3" creationId="{A6FA23DB-2026-F938-2B1A-401CADD258D7}"/>
+          </ac:spMkLst>
+        </pc:spChg>
+      </pc:sldChg>
+      <pc:sldChg chg="modSp mod">
+        <pc:chgData name="Matthieu De Mari" userId="dfb708c9-d8dc-439f-9a3b-c772bf4a311c" providerId="ADAL" clId="{81E9B007-0C2C-493E-9B93-55A62C9C1F12}" dt="2026-03-05T04:37:37.040" v="6" actId="20577"/>
+        <pc:sldMkLst>
+          <pc:docMk/>
+          <pc:sldMk cId="783589184" sldId="449"/>
+        </pc:sldMkLst>
+        <pc:spChg chg="mod">
+          <ac:chgData name="Matthieu De Mari" userId="dfb708c9-d8dc-439f-9a3b-c772bf4a311c" providerId="ADAL" clId="{81E9B007-0C2C-493E-9B93-55A62C9C1F12}" dt="2026-03-05T04:37:37.040" v="6" actId="20577"/>
+          <ac:spMkLst>
+            <pc:docMk/>
+            <pc:sldMk cId="783589184" sldId="449"/>
+            <ac:spMk id="3" creationId="{A6FA23DB-2026-F938-2B1A-401CADD258D7}"/>
+          </ac:spMkLst>
+        </pc:spChg>
+      </pc:sldChg>
+      <pc:sldChg chg="modSp mod">
+        <pc:chgData name="Matthieu De Mari" userId="dfb708c9-d8dc-439f-9a3b-c772bf4a311c" providerId="ADAL" clId="{81E9B007-0C2C-493E-9B93-55A62C9C1F12}" dt="2026-03-05T04:38:08.316" v="11" actId="20577"/>
+        <pc:sldMkLst>
+          <pc:docMk/>
+          <pc:sldMk cId="3093658865" sldId="452"/>
+        </pc:sldMkLst>
+        <pc:spChg chg="mod">
+          <ac:chgData name="Matthieu De Mari" userId="dfb708c9-d8dc-439f-9a3b-c772bf4a311c" providerId="ADAL" clId="{81E9B007-0C2C-493E-9B93-55A62C9C1F12}" dt="2026-03-05T04:38:08.316" v="11" actId="20577"/>
+          <ac:spMkLst>
+            <pc:docMk/>
+            <pc:sldMk cId="3093658865" sldId="452"/>
+            <ac:spMk id="3" creationId="{A6FA23DB-2026-F938-2B1A-401CADD258D7}"/>
+          </ac:spMkLst>
+        </pc:spChg>
+      </pc:sldChg>
+      <pc:sldChg chg="modSp mod">
+        <pc:chgData name="Matthieu De Mari" userId="dfb708c9-d8dc-439f-9a3b-c772bf4a311c" providerId="ADAL" clId="{81E9B007-0C2C-493E-9B93-55A62C9C1F12}" dt="2026-03-05T04:45:32.466" v="14" actId="20577"/>
+        <pc:sldMkLst>
+          <pc:docMk/>
+          <pc:sldMk cId="1432686963" sldId="468"/>
+        </pc:sldMkLst>
+        <pc:spChg chg="mod">
+          <ac:chgData name="Matthieu De Mari" userId="dfb708c9-d8dc-439f-9a3b-c772bf4a311c" providerId="ADAL" clId="{81E9B007-0C2C-493E-9B93-55A62C9C1F12}" dt="2026-03-05T04:45:32.466" v="14" actId="20577"/>
+          <ac:spMkLst>
+            <pc:docMk/>
+            <pc:sldMk cId="1432686963" sldId="468"/>
+            <ac:spMk id="4" creationId="{5D0D450B-C201-FDB7-239F-6DE0626BCB23}"/>
           </ac:spMkLst>
         </pc:spChg>
       </pc:sldChg>
@@ -441,7 +501,7 @@
           <a:p>
             <a:fld id="{98CFC6A4-B085-437B-8084-693BEB2A32DE}" type="datetimeFigureOut">
               <a:rPr lang="en-SG" smtClean="0"/>
-              <a:t>3/3/2026</a:t>
+              <a:t>5/3/2026</a:t>
             </a:fld>
             <a:endParaRPr lang="en-SG"/>
           </a:p>
@@ -858,7 +918,7 @@
           <a:p>
             <a:fld id="{AB35F6B0-D468-4997-9CE3-CF2A1AE5E3F9}" type="datetimeFigureOut">
               <a:rPr lang="en-SG" smtClean="0"/>
-              <a:t>3/3/2026</a:t>
+              <a:t>5/3/2026</a:t>
             </a:fld>
             <a:endParaRPr lang="en-SG"/>
           </a:p>
@@ -1058,7 +1118,7 @@
           <a:p>
             <a:fld id="{AB35F6B0-D468-4997-9CE3-CF2A1AE5E3F9}" type="datetimeFigureOut">
               <a:rPr lang="en-SG" smtClean="0"/>
-              <a:t>3/3/2026</a:t>
+              <a:t>5/3/2026</a:t>
             </a:fld>
             <a:endParaRPr lang="en-SG"/>
           </a:p>
@@ -1268,7 +1328,7 @@
           <a:p>
             <a:fld id="{AB35F6B0-D468-4997-9CE3-CF2A1AE5E3F9}" type="datetimeFigureOut">
               <a:rPr lang="en-SG" smtClean="0"/>
-              <a:t>3/3/2026</a:t>
+              <a:t>5/3/2026</a:t>
             </a:fld>
             <a:endParaRPr lang="en-SG"/>
           </a:p>
@@ -1468,7 +1528,7 @@
           <a:p>
             <a:fld id="{AB35F6B0-D468-4997-9CE3-CF2A1AE5E3F9}" type="datetimeFigureOut">
               <a:rPr lang="en-SG" smtClean="0"/>
-              <a:t>3/3/2026</a:t>
+              <a:t>5/3/2026</a:t>
             </a:fld>
             <a:endParaRPr lang="en-SG"/>
           </a:p>
@@ -1744,7 +1804,7 @@
           <a:p>
             <a:fld id="{AB35F6B0-D468-4997-9CE3-CF2A1AE5E3F9}" type="datetimeFigureOut">
               <a:rPr lang="en-SG" smtClean="0"/>
-              <a:t>3/3/2026</a:t>
+              <a:t>5/3/2026</a:t>
             </a:fld>
             <a:endParaRPr lang="en-SG"/>
           </a:p>
@@ -2012,7 +2072,7 @@
           <a:p>
             <a:fld id="{AB35F6B0-D468-4997-9CE3-CF2A1AE5E3F9}" type="datetimeFigureOut">
               <a:rPr lang="en-SG" smtClean="0"/>
-              <a:t>3/3/2026</a:t>
+              <a:t>5/3/2026</a:t>
             </a:fld>
             <a:endParaRPr lang="en-SG"/>
           </a:p>
@@ -2427,7 +2487,7 @@
           <a:p>
             <a:fld id="{AB35F6B0-D468-4997-9CE3-CF2A1AE5E3F9}" type="datetimeFigureOut">
               <a:rPr lang="en-SG" smtClean="0"/>
-              <a:t>3/3/2026</a:t>
+              <a:t>5/3/2026</a:t>
             </a:fld>
             <a:endParaRPr lang="en-SG"/>
           </a:p>
@@ -2569,7 +2629,7 @@
           <a:p>
             <a:fld id="{AB35F6B0-D468-4997-9CE3-CF2A1AE5E3F9}" type="datetimeFigureOut">
               <a:rPr lang="en-SG" smtClean="0"/>
-              <a:t>3/3/2026</a:t>
+              <a:t>5/3/2026</a:t>
             </a:fld>
             <a:endParaRPr lang="en-SG"/>
           </a:p>
@@ -2682,7 +2742,7 @@
           <a:p>
             <a:fld id="{AB35F6B0-D468-4997-9CE3-CF2A1AE5E3F9}" type="datetimeFigureOut">
               <a:rPr lang="en-SG" smtClean="0"/>
-              <a:t>3/3/2026</a:t>
+              <a:t>5/3/2026</a:t>
             </a:fld>
             <a:endParaRPr lang="en-SG"/>
           </a:p>
@@ -2995,7 +3055,7 @@
           <a:p>
             <a:fld id="{AB35F6B0-D468-4997-9CE3-CF2A1AE5E3F9}" type="datetimeFigureOut">
               <a:rPr lang="en-SG" smtClean="0"/>
-              <a:t>3/3/2026</a:t>
+              <a:t>5/3/2026</a:t>
             </a:fld>
             <a:endParaRPr lang="en-SG"/>
           </a:p>
@@ -3284,7 +3344,7 @@
           <a:p>
             <a:fld id="{AB35F6B0-D468-4997-9CE3-CF2A1AE5E3F9}" type="datetimeFigureOut">
               <a:rPr lang="en-SG" smtClean="0"/>
-              <a:t>3/3/2026</a:t>
+              <a:t>5/3/2026</a:t>
             </a:fld>
             <a:endParaRPr lang="en-SG"/>
           </a:p>
@@ -3527,7 +3587,7 @@
           <a:p>
             <a:fld id="{AB35F6B0-D468-4997-9CE3-CF2A1AE5E3F9}" type="datetimeFigureOut">
               <a:rPr lang="en-SG" smtClean="0"/>
-              <a:t>3/3/2026</a:t>
+              <a:t>5/3/2026</a:t>
             </a:fld>
             <a:endParaRPr lang="en-SG"/>
           </a:p>
@@ -11570,7 +11630,7 @@
           <a:p>
             <a:r>
               <a:rPr lang="en-GB" dirty="0"/>
-              <a:t>0123followedbyletters</a:t>
+              <a:t>123followedbyletters</a:t>
             </a:r>
           </a:p>
         </p:txBody>
@@ -12344,7 +12404,7 @@
                   <a:srgbClr val="7030A0"/>
                 </a:solidFill>
               </a:rPr>
-              <a:t>“^[-+]?((0|[1-9]\\d*)(\\.\\d*)?)$”</a:t>
+              <a:t>“^[-\\+]?((0|[1-9]\\d*)(\\.\\d*)?)$”</a:t>
             </a:r>
             <a:endParaRPr lang="en-SG" dirty="0"/>
           </a:p>
@@ -12530,7 +12590,7 @@
             </a:br>
             <a:r>
               <a:rPr lang="en-GB" b="1" dirty="0"/>
-              <a:t>e.g. 1e+5, 0.25e-17, etc.?</a:t>
+              <a:t>e.g. 1e+5, 0.25e-17, .25, etc.?</a:t>
             </a:r>
           </a:p>
           <a:p>
@@ -13362,8 +13422,21 @@
                   <a:srgbClr val="7030A0"/>
                 </a:solidFill>
               </a:rPr>
-              <a:t>“^[0-9]+[^0-9]+”</a:t>
-            </a:r>
+              <a:t>“^[0-9]+[^</a:t>
+            </a:r>
+            <a:r>
+              <a:rPr lang="en-GB" b="1">
+                <a:solidFill>
+                  <a:srgbClr val="7030A0"/>
+                </a:solidFill>
+              </a:rPr>
+              <a:t>0-9].*”</a:t>
+            </a:r>
+            <a:endParaRPr lang="en-GB" b="1" dirty="0">
+              <a:solidFill>
+                <a:srgbClr val="7030A0"/>
+              </a:solidFill>
+            </a:endParaRPr>
           </a:p>
           <a:p>
             <a:endParaRPr lang="en-GB" dirty="0"/>

</xml_diff>